<commit_message>
feat: embed live project photos, architecture flowcharts, and crisp bullet cards in SIH pitch deck
</commit_message>
<xml_diff>
--- a/AgriConnect-Maharashtra-SIH2026-Presentation.pptx
+++ b/AgriConnect-Maharashtra-SIH2026-Presentation.pptx
@@ -5540,7 +5540,7 @@
         </p:nvSpPr>
         <p:spPr>
           <a:xfrm>
-            <a:off x="329184" y="1188720"/>
+            <a:off x="365760" y="1143000"/>
             <a:ext cx="8686800" cy="822960"/>
           </a:xfrm>
         </p:spPr>
@@ -5551,7 +5551,7 @@
             <a:pPr>
               <a:defRPr sz="2000" b="1">
                 <a:solidFill>
-                  <a:srgbClr val="065F46"/>
+                  <a:srgbClr val="047857"/>
                 </a:solidFill>
                 <a:latin typeface="Arial"/>
               </a:defRPr>
@@ -5572,9 +5572,9 @@
               <a:spcBef>
                 <a:spcPts val="300"/>
               </a:spcBef>
-              <a:defRPr sz="1300" b="0">
-                <a:solidFill>
-                  <a:srgbClr val="4B5563"/>
+              <a:defRPr sz="1250" b="0">
+                <a:solidFill>
+                  <a:srgbClr val="475569"/>
                 </a:solidFill>
                 <a:latin typeface="Arial"/>
               </a:defRPr>
@@ -5597,8 +5597,8 @@
         </p:nvSpPr>
         <p:spPr>
           <a:xfrm>
-            <a:off x="329184" y="182880"/>
-            <a:ext cx="10363200" cy="1005840"/>
+            <a:off x="365760" y="228600"/>
+            <a:ext cx="10363200" cy="914400"/>
           </a:xfrm>
         </p:spPr>
         <p:txBody>
@@ -5606,7 +5606,7 @@
           <a:lstStyle/>
           <a:p>
             <a:pPr>
-              <a:defRPr sz="3600" b="1">
+              <a:defRPr sz="3400" b="1">
                 <a:solidFill>
                   <a:srgbClr val="0F172A"/>
                 </a:solidFill>
@@ -5633,8 +5633,8 @@
         </p:nvSpPr>
         <p:spPr>
           <a:xfrm>
-            <a:off x="329184" y="2148840"/>
-            <a:ext cx="6858000" cy="4114800"/>
+            <a:off x="365760" y="2148840"/>
+            <a:ext cx="6583680" cy="4114800"/>
           </a:xfrm>
           <a:prstGeom prst="rect">
             <a:avLst/>
@@ -5653,18 +5653,18 @@
               </a:spcAft>
             </a:pPr>
             <a:r>
-              <a:rPr sz="1250" b="1">
-                <a:solidFill>
-                  <a:srgbClr val="065F46"/>
+              <a:rPr sz="1200" b="1">
+                <a:solidFill>
+                  <a:srgbClr val="047857"/>
                 </a:solidFill>
                 <a:latin typeface="Arial"/>
               </a:rPr>
               <a:t>Problem Statement: </a:t>
             </a:r>
             <a:r>
-              <a:rPr sz="1250" b="0">
-                <a:solidFill>
-                  <a:srgbClr val="1F2937"/>
+              <a:rPr sz="1200" b="0">
+                <a:solidFill>
+                  <a:srgbClr val="1E293B"/>
                 </a:solidFill>
                 <a:latin typeface="Arial"/>
               </a:rPr>
@@ -5679,18 +5679,18 @@
               </a:spcAft>
             </a:pPr>
             <a:r>
-              <a:rPr sz="1250" b="1">
-                <a:solidFill>
-                  <a:srgbClr val="065F46"/>
+              <a:rPr sz="1200" b="1">
+                <a:solidFill>
+                  <a:srgbClr val="047857"/>
                 </a:solidFill>
                 <a:latin typeface="Arial"/>
               </a:rPr>
               <a:t>Ministry / Organization: </a:t>
             </a:r>
             <a:r>
-              <a:rPr sz="1250" b="0">
-                <a:solidFill>
-                  <a:srgbClr val="1F2937"/>
+              <a:rPr sz="1200" b="0">
+                <a:solidFill>
+                  <a:srgbClr val="1E293B"/>
                 </a:solidFill>
                 <a:latin typeface="Arial"/>
               </a:rPr>
@@ -5704,18 +5704,18 @@
               </a:spcAft>
             </a:pPr>
             <a:r>
-              <a:rPr sz="1250" b="1">
-                <a:solidFill>
-                  <a:srgbClr val="065F46"/>
+              <a:rPr sz="1200" b="1">
+                <a:solidFill>
+                  <a:srgbClr val="047857"/>
                 </a:solidFill>
                 <a:latin typeface="Arial"/>
               </a:rPr>
               <a:t>Theme: </a:t>
             </a:r>
             <a:r>
-              <a:rPr sz="1250" b="0">
-                <a:solidFill>
-                  <a:srgbClr val="1F2937"/>
+              <a:rPr sz="1200" b="0">
+                <a:solidFill>
+                  <a:srgbClr val="1E293B"/>
                 </a:solidFill>
                 <a:latin typeface="Arial"/>
               </a:rPr>
@@ -5729,18 +5729,18 @@
               </a:spcAft>
             </a:pPr>
             <a:r>
-              <a:rPr sz="1250" b="1">
-                <a:solidFill>
-                  <a:srgbClr val="065F46"/>
+              <a:rPr sz="1200" b="1">
+                <a:solidFill>
+                  <a:srgbClr val="047857"/>
                 </a:solidFill>
                 <a:latin typeface="Arial"/>
               </a:rPr>
               <a:t>Category: </a:t>
             </a:r>
             <a:r>
-              <a:rPr sz="1250" b="0">
-                <a:solidFill>
-                  <a:srgbClr val="1F2937"/>
+              <a:rPr sz="1200" b="0">
+                <a:solidFill>
+                  <a:srgbClr val="1E293B"/>
                 </a:solidFill>
                 <a:latin typeface="Arial"/>
               </a:rPr>
@@ -5754,18 +5754,18 @@
               </a:spcAft>
             </a:pPr>
             <a:r>
-              <a:rPr sz="1250" b="1">
-                <a:solidFill>
-                  <a:srgbClr val="065F46"/>
+              <a:rPr sz="1200" b="1">
+                <a:solidFill>
+                  <a:srgbClr val="047857"/>
                 </a:solidFill>
                 <a:latin typeface="Arial"/>
               </a:rPr>
               <a:t>Team Name: </a:t>
             </a:r>
             <a:r>
-              <a:rPr sz="1250" b="0">
-                <a:solidFill>
-                  <a:srgbClr val="1F2937"/>
+              <a:rPr sz="1200" b="0">
+                <a:solidFill>
+                  <a:srgbClr val="1E293B"/>
                 </a:solidFill>
                 <a:latin typeface="Arial"/>
               </a:rPr>
@@ -5779,18 +5779,18 @@
               </a:spcAft>
             </a:pPr>
             <a:r>
-              <a:rPr sz="1250" b="1">
-                <a:solidFill>
-                  <a:srgbClr val="065F46"/>
+              <a:rPr sz="1200" b="1">
+                <a:solidFill>
+                  <a:srgbClr val="047857"/>
                 </a:solidFill>
                 <a:latin typeface="Arial"/>
               </a:rPr>
               <a:t>Live Prototype: </a:t>
             </a:r>
             <a:r>
-              <a:rPr sz="1250" b="0">
-                <a:solidFill>
-                  <a:srgbClr val="1F2937"/>
+              <a:rPr sz="1200" b="0">
+                <a:solidFill>
+                  <a:srgbClr val="1E293B"/>
                 </a:solidFill>
                 <a:latin typeface="Arial"/>
               </a:rPr>
@@ -5804,18 +5804,18 @@
               </a:spcAft>
             </a:pPr>
             <a:r>
-              <a:rPr sz="1250" b="1">
-                <a:solidFill>
-                  <a:srgbClr val="065F46"/>
+              <a:rPr sz="1200" b="1">
+                <a:solidFill>
+                  <a:srgbClr val="047857"/>
                 </a:solidFill>
                 <a:latin typeface="Arial"/>
               </a:rPr>
               <a:t>GitHub Repository: </a:t>
             </a:r>
             <a:r>
-              <a:rPr sz="1250" b="0">
-                <a:solidFill>
-                  <a:srgbClr val="1F2937"/>
+              <a:rPr sz="1200" b="0">
+                <a:solidFill>
+                  <a:srgbClr val="1E293B"/>
                 </a:solidFill>
                 <a:latin typeface="Arial"/>
               </a:rPr>
@@ -5949,7 +5949,7 @@
         </p:nvSpPr>
         <p:spPr>
           <a:xfrm>
-            <a:off x="182998" y="0"/>
+            <a:off x="548640" y="182880"/>
             <a:ext cx="10972800" cy="1143000"/>
           </a:xfrm>
         </p:spPr>
@@ -5958,7 +5958,7 @@
           <a:lstStyle/>
           <a:p>
             <a:pPr eaLnBrk="1" hangingPunct="1">
-              <a:defRPr sz="2200" b="1">
+              <a:defRPr sz="2100" b="1">
                 <a:solidFill>
                   <a:srgbClr val="0F172A"/>
                 </a:solidFill>
@@ -5981,8 +5981,8 @@
         </p:nvSpPr>
         <p:spPr bwMode="auto">
           <a:xfrm>
-            <a:off x="548640" y="1234440"/>
-            <a:ext cx="11064240" cy="4937760"/>
+            <a:off x="457200" y="1143000"/>
+            <a:ext cx="5303520" cy="4937760"/>
           </a:xfrm>
           <a:prstGeom prst="rect">
             <a:avLst/>
@@ -6005,15 +6005,15 @@
               <a:spcAft>
                 <a:spcPts val="400"/>
               </a:spcAft>
+              <a:defRPr sz="1400" b="1">
+                <a:solidFill>
+                  <a:srgbClr val="047857"/>
+                </a:solidFill>
+                <a:latin typeface="Arial"/>
+              </a:defRPr>
             </a:pPr>
             <a:r>
-              <a:rPr sz="1500" b="1">
-                <a:solidFill>
-                  <a:srgbClr val="065F46"/>
-                </a:solidFill>
-                <a:latin typeface="Arial"/>
-              </a:rPr>
-              <a:t>PROPOSED SOLUTION</a:t>
+              <a:t>CORE CAPABILITIES</a:t>
             </a:r>
           </a:p>
           <a:p>
@@ -6023,22 +6023,22 @@
               </a:spcAft>
             </a:pPr>
             <a:r>
-              <a:rPr sz="1150" b="1">
-                <a:solidFill>
-                  <a:srgbClr val="1F2937"/>
-                </a:solidFill>
-                <a:latin typeface="Arial"/>
-              </a:rPr>
-              <a:t>• Real-Time APMC Price Intelligence &amp; Predictive Analytics: </a:t>
-            </a:r>
-            <a:r>
-              <a:rPr sz="1150" b="0">
-                <a:solidFill>
-                  <a:srgbClr val="4B5563"/>
-                </a:solidFill>
-                <a:latin typeface="Arial"/>
-              </a:rPr>
-              <a:t>Ingests live mandi telemetry across Maharashtra (Lasalgaon, Pune, Nashik, Kolhapur, etc.) with 7d/14d EMA trends and heuristic Hold/Sell advisory to stop distress selling.</a:t>
+              <a:rPr sz="1100" b="1">
+                <a:solidFill>
+                  <a:srgbClr val="1E293B"/>
+                </a:solidFill>
+                <a:latin typeface="Arial"/>
+              </a:rPr>
+              <a:t>• APMC Price Telemetry: </a:t>
+            </a:r>
+            <a:r>
+              <a:rPr sz="1100" b="0">
+                <a:solidFill>
+                  <a:srgbClr val="475569"/>
+                </a:solidFill>
+                <a:latin typeface="Arial"/>
+              </a:rPr>
+              <a:t>Live rates across 6 major hubs with 7d/14d EMA Sell/Hold advisory.</a:t>
             </a:r>
           </a:p>
           <a:p>
@@ -6048,22 +6048,22 @@
               </a:spcAft>
             </a:pPr>
             <a:r>
-              <a:rPr sz="1150" b="1">
-                <a:solidFill>
-                  <a:srgbClr val="1F2937"/>
-                </a:solidFill>
-                <a:latin typeface="Arial"/>
-              </a:rPr>
-              <a:t>• FPO Fractional Lot Aggregation &amp; Pooling: </a:t>
-            </a:r>
-            <a:r>
-              <a:rPr sz="1150" b="0">
-                <a:solidFill>
-                  <a:srgbClr val="4B5563"/>
-                </a:solidFill>
-                <a:latin typeface="Arial"/>
-              </a:rPr>
-              <a:t>Enables smallholders to pool sub-ton harvests into commercial Grade-A lots with transparent percentage-share accounting.</a:t>
+              <a:rPr sz="1100" b="1">
+                <a:solidFill>
+                  <a:srgbClr val="1E293B"/>
+                </a:solidFill>
+                <a:latin typeface="Arial"/>
+              </a:rPr>
+              <a:t>• Fractional Lot Pooling: </a:t>
+            </a:r>
+            <a:r>
+              <a:rPr sz="1100" b="0">
+                <a:solidFill>
+                  <a:srgbClr val="475569"/>
+                </a:solidFill>
+                <a:latin typeface="Arial"/>
+              </a:rPr>
+              <a:t>Aggregates small harvests into Grade-A commercial bulk lots.</a:t>
             </a:r>
           </a:p>
           <a:p>
@@ -6073,22 +6073,22 @@
               </a:spcAft>
             </a:pPr>
             <a:r>
-              <a:rPr sz="1150" b="1">
-                <a:solidFill>
-                  <a:srgbClr val="1F2937"/>
-                </a:solidFill>
-                <a:latin typeface="Arial"/>
-              </a:rPr>
-              <a:t>• Verifiable Digital Lot Passport &amp; QR: </a:t>
-            </a:r>
-            <a:r>
-              <a:rPr sz="1150" b="0">
-                <a:solidFill>
-                  <a:srgbClr val="4B5563"/>
-                </a:solidFill>
-                <a:latin typeface="Arial"/>
-              </a:rPr>
-              <a:t>Generates tamper-proof SHA-256 passports recording harvest date, moisture %, visual grade, and MSWC cold storage suitability.</a:t>
+              <a:rPr sz="1100" b="1">
+                <a:solidFill>
+                  <a:srgbClr val="1E293B"/>
+                </a:solidFill>
+                <a:latin typeface="Arial"/>
+              </a:rPr>
+              <a:t>• Digital Lot Passport: </a:t>
+            </a:r>
+            <a:r>
+              <a:rPr sz="1100" b="0">
+                <a:solidFill>
+                  <a:srgbClr val="475569"/>
+                </a:solidFill>
+                <a:latin typeface="Arial"/>
+              </a:rPr>
+              <a:t>Tamper-proof SHA-256 QR certificate with moisture &amp; grade metrics.</a:t>
             </a:r>
           </a:p>
           <a:p>
@@ -6098,22 +6098,22 @@
               </a:spcAft>
             </a:pPr>
             <a:r>
-              <a:rPr sz="1150" b="1">
-                <a:solidFill>
-                  <a:srgbClr val="1F2937"/>
-                </a:solidFill>
-                <a:latin typeface="Arial"/>
-              </a:rPr>
-              <a:t>• 7-Stage Milestone Escrow Protocol: </a:t>
-            </a:r>
-            <a:r>
-              <a:rPr sz="1150" b="0">
-                <a:solidFill>
-                  <a:srgbClr val="4B5563"/>
-                </a:solidFill>
-                <a:latin typeface="Arial"/>
-              </a:rPr>
-              <a:t>Eliminates payment defaults by locking buyer funds in trust prior to dispatch, releasing payout upon digital weighment.</a:t>
+              <a:rPr sz="1100" b="1">
+                <a:solidFill>
+                  <a:srgbClr val="1E293B"/>
+                </a:solidFill>
+                <a:latin typeface="Arial"/>
+              </a:rPr>
+              <a:t>• Milestone Escrow: </a:t>
+            </a:r>
+            <a:r>
+              <a:rPr sz="1100" b="0">
+                <a:solidFill>
+                  <a:srgbClr val="475569"/>
+                </a:solidFill>
+                <a:latin typeface="Arial"/>
+              </a:rPr>
+              <a:t>100% payment security locking buyer funds before dispatch.</a:t>
             </a:r>
           </a:p>
           <a:p>
@@ -6124,15 +6124,15 @@
               <a:spcAft>
                 <a:spcPts val="400"/>
               </a:spcAft>
+              <a:defRPr sz="1400" b="1">
+                <a:solidFill>
+                  <a:srgbClr val="047857"/>
+                </a:solidFill>
+                <a:latin typeface="Arial"/>
+              </a:defRPr>
             </a:pPr>
             <a:r>
-              <a:rPr sz="1500" b="1">
-                <a:solidFill>
-                  <a:srgbClr val="065F46"/>
-                </a:solidFill>
-                <a:latin typeface="Arial"/>
-              </a:rPr>
-              <a:t>INNOVATION &amp; UNIQUENESS</a:t>
+              <a:t>INNOVATION &amp; VALUE ADD</a:t>
             </a:r>
           </a:p>
           <a:p>
@@ -6142,22 +6142,22 @@
               </a:spcAft>
             </a:pPr>
             <a:r>
-              <a:rPr sz="1150" b="1">
-                <a:solidFill>
-                  <a:srgbClr val="1F2937"/>
+              <a:rPr sz="1100" b="1">
+                <a:solidFill>
+                  <a:srgbClr val="1E293B"/>
                 </a:solidFill>
                 <a:latin typeface="Arial"/>
               </a:rPr>
               <a:t>• Mandi Arbitrage Matrix: </a:t>
             </a:r>
             <a:r>
-              <a:rPr sz="1150" b="0">
-                <a:solidFill>
-                  <a:srgbClr val="4B5563"/>
-                </a:solidFill>
-                <a:latin typeface="Arial"/>
-              </a:rPr>
-              <a:t>Calculates net margins across neighboring APMCs factoring in distance and freight economics (₹/km) for optimal dispatch.</a:t>
+              <a:rPr sz="1100" b="0">
+                <a:solidFill>
+                  <a:srgbClr val="475569"/>
+                </a:solidFill>
+                <a:latin typeface="Arial"/>
+              </a:rPr>
+              <a:t>Real-time freight deduction (₹/km) for optimal market dispatch.</a:t>
             </a:r>
           </a:p>
           <a:p>
@@ -6167,22 +6167,22 @@
               </a:spcAft>
             </a:pPr>
             <a:r>
-              <a:rPr sz="1150" b="1">
-                <a:solidFill>
-                  <a:srgbClr val="1F2937"/>
-                </a:solidFill>
-                <a:latin typeface="Arial"/>
-              </a:rPr>
-              <a:t>• Automated Fair-Share Payout Ledger: </a:t>
-            </a:r>
-            <a:r>
-              <a:rPr sz="1150" b="0">
-                <a:solidFill>
-                  <a:srgbClr val="4B5563"/>
-                </a:solidFill>
-                <a:latin typeface="Arial"/>
-              </a:rPr>
-              <a:t>Instantly splits escrow funds directly into individual farmers' DBT accounts upon certified weighment sign-off.</a:t>
+              <a:rPr sz="1100" b="1">
+                <a:solidFill>
+                  <a:srgbClr val="1E293B"/>
+                </a:solidFill>
+                <a:latin typeface="Arial"/>
+              </a:rPr>
+              <a:t>• Automated Fair Payout: </a:t>
+            </a:r>
+            <a:r>
+              <a:rPr sz="1100" b="0">
+                <a:solidFill>
+                  <a:srgbClr val="475569"/>
+                </a:solidFill>
+                <a:latin typeface="Arial"/>
+              </a:rPr>
+              <a:t>Direct split disbursements to farmers' bank accounts upon weighment.</a:t>
             </a:r>
           </a:p>
           <a:p>
@@ -6192,22 +6192,22 @@
               </a:spcAft>
             </a:pPr>
             <a:r>
-              <a:rPr sz="1150" b="1">
-                <a:solidFill>
-                  <a:srgbClr val="1F2937"/>
-                </a:solidFill>
-                <a:latin typeface="Arial"/>
-              </a:rPr>
-              <a:t>• State Administrative Oversight: </a:t>
-            </a:r>
-            <a:r>
-              <a:rPr sz="1150" b="0">
-                <a:solidFill>
-                  <a:srgbClr val="4B5563"/>
-                </a:solidFill>
-                <a:latin typeface="Arial"/>
-              </a:rPr>
-              <a:t>Dedicated Government dashboard providing live mandi arrival trends, distress sale heatmaps, and digital dispute arbitration.</a:t>
+              <a:rPr sz="1100" b="1">
+                <a:solidFill>
+                  <a:srgbClr val="1E293B"/>
+                </a:solidFill>
+                <a:latin typeface="Arial"/>
+              </a:rPr>
+              <a:t>• State Telemetry: </a:t>
+            </a:r>
+            <a:r>
+              <a:rPr sz="1100" b="0">
+                <a:solidFill>
+                  <a:srgbClr val="475569"/>
+                </a:solidFill>
+                <a:latin typeface="Arial"/>
+              </a:rPr>
+              <a:t>Administrative dashboard for mandi monitoring &amp; dispute arbitration.</a:t>
             </a:r>
           </a:p>
           <a:p>
@@ -6217,22 +6217,22 @@
               </a:spcAft>
             </a:pPr>
             <a:r>
-              <a:rPr sz="1150" b="1">
-                <a:solidFill>
-                  <a:srgbClr val="1F2937"/>
-                </a:solidFill>
-                <a:latin typeface="Arial"/>
-              </a:rPr>
-              <a:t>• Rural Vernacular UX &amp; Offline PWA: </a:t>
-            </a:r>
-            <a:r>
-              <a:rPr sz="1150" b="0">
-                <a:solidFill>
-                  <a:srgbClr val="4B5563"/>
-                </a:solidFill>
-                <a:latin typeface="Arial"/>
-              </a:rPr>
-              <a:t>100% Marathi/English interface with high-contrast visual stages and resilient offline mock data fallback.</a:t>
+              <a:rPr sz="1100" b="1">
+                <a:solidFill>
+                  <a:srgbClr val="1E293B"/>
+                </a:solidFill>
+                <a:latin typeface="Arial"/>
+              </a:rPr>
+              <a:t>• Vernacular Rural UX: </a:t>
+            </a:r>
+            <a:r>
+              <a:rPr sz="1100" b="0">
+                <a:solidFill>
+                  <a:srgbClr val="475569"/>
+                </a:solidFill>
+                <a:latin typeface="Arial"/>
+              </a:rPr>
+              <a:t>100% Marathi/English toggle with PWA offline resilience.</a:t>
             </a:r>
           </a:p>
         </p:txBody>
@@ -6399,6 +6399,93 @@
           </a:prstGeom>
         </p:spPr>
       </p:pic>
+      <p:pic>
+        <p:nvPicPr>
+          <p:cNvPr id="15363" name="Picture 15362" descr="price_intelligence.png"/>
+          <p:cNvPicPr>
+            <a:picLocks noChangeAspect="1"/>
+          </p:cNvPicPr>
+          <p:nvPr/>
+        </p:nvPicPr>
+        <p:blipFill>
+          <a:blip r:embed="rId4"/>
+          <a:stretch>
+            <a:fillRect/>
+          </a:stretch>
+        </p:blipFill>
+        <p:spPr>
+          <a:xfrm>
+            <a:off x="5943600" y="1188720"/>
+            <a:ext cx="5760720" cy="3703320"/>
+          </a:xfrm>
+          <a:prstGeom prst="rect">
+            <a:avLst/>
+          </a:prstGeom>
+        </p:spPr>
+      </p:pic>
+      <p:sp>
+        <p:nvSpPr>
+          <p:cNvPr id="15364" name="Rounded Rectangle 15363"/>
+          <p:cNvSpPr/>
+          <p:nvPr/>
+        </p:nvSpPr>
+        <p:spPr>
+          <a:xfrm>
+            <a:off x="5943600" y="4983480"/>
+            <a:ext cx="5760720" cy="594360"/>
+          </a:xfrm>
+          <a:prstGeom prst="roundRect">
+            <a:avLst/>
+          </a:prstGeom>
+          <a:solidFill>
+            <a:srgbClr val="F1F5F9"/>
+          </a:solidFill>
+          <a:ln w="12700">
+            <a:solidFill>
+              <a:srgbClr val="CBD5E1"/>
+            </a:solidFill>
+          </a:ln>
+        </p:spPr>
+        <p:style>
+          <a:lnRef idx="1">
+            <a:schemeClr val="accent1"/>
+          </a:lnRef>
+          <a:fillRef idx="3">
+            <a:schemeClr val="accent1"/>
+          </a:fillRef>
+          <a:effectRef idx="2">
+            <a:schemeClr val="accent1"/>
+          </a:effectRef>
+          <a:fontRef idx="minor">
+            <a:schemeClr val="lt1"/>
+          </a:fontRef>
+        </p:style>
+        <p:txBody>
+          <a:bodyPr rtlCol="0" anchor="ctr" wrap="square"/>
+          <a:lstStyle/>
+          <a:p>
+            <a:pPr algn="ctr"/>
+            <a:r>
+              <a:rPr sz="1050" b="1">
+                <a:solidFill>
+                  <a:srgbClr val="1E293B"/>
+                </a:solidFill>
+                <a:latin typeface="Arial"/>
+              </a:rPr>
+              <a:t>Live Production UI — </a:t>
+            </a:r>
+            <a:r>
+              <a:rPr sz="1000" b="0">
+                <a:solidFill>
+                  <a:srgbClr val="475569"/>
+                </a:solidFill>
+                <a:latin typeface="Arial"/>
+              </a:rPr>
+              <a:t>Real-time APMC Mandi Price Discovery &amp; Sell/Hold Advisory</a:t>
+            </a:r>
+          </a:p>
+        </p:txBody>
+      </p:sp>
     </p:spTree>
   </p:cSld>
   <p:clrMapOvr>
@@ -6498,13 +6585,17 @@
             <p:ph type="title"/>
           </p:nvPr>
         </p:nvSpPr>
-        <p:spPr/>
+        <p:spPr>
+          <a:xfrm>
+            <a:off x="548640" y="182880"/>
+          </a:xfrm>
+        </p:spPr>
         <p:txBody>
           <a:bodyPr/>
           <a:lstStyle/>
           <a:p>
             <a:pPr eaLnBrk="1" hangingPunct="1">
-              <a:defRPr sz="2200" b="1">
+              <a:defRPr sz="2100" b="1">
                 <a:solidFill>
                   <a:srgbClr val="0F172A"/>
                 </a:solidFill>
@@ -6704,8 +6795,8 @@
         </p:nvSpPr>
         <p:spPr>
           <a:xfrm>
-            <a:off x="548640" y="1234440"/>
-            <a:ext cx="11064240" cy="4937760"/>
+            <a:off x="457200" y="1143000"/>
+            <a:ext cx="5120640" cy="4937760"/>
           </a:xfrm>
           <a:prstGeom prst="rect">
             <a:avLst/>
@@ -6724,140 +6815,140 @@
               </a:spcAft>
               <a:buFont typeface="Arial" panose="020B0604020202020204" pitchFamily="34" charset="0"/>
               <a:buChar char="•"/>
+              <a:defRPr sz="1400" b="1">
+                <a:solidFill>
+                  <a:srgbClr val="047857"/>
+                </a:solidFill>
+                <a:latin typeface="Arial"/>
+              </a:defRPr>
             </a:pPr>
             <a:r>
-              <a:rPr sz="1500" b="1">
-                <a:solidFill>
-                  <a:srgbClr val="065F46"/>
-                </a:solidFill>
-                <a:latin typeface="Arial"/>
-              </a:rPr>
-              <a:t>PRODUCTION TECHNOLOGY STACK</a:t>
+              <a:t>PRODUCTION TECH STACK</a:t>
             </a:r>
           </a:p>
           <a:p>
             <a:pPr>
               <a:spcAft>
-                <a:spcPts val="300"/>
+                <a:spcPts val="350"/>
               </a:spcAft>
             </a:pPr>
             <a:r>
               <a:rPr sz="1100" b="1">
                 <a:solidFill>
-                  <a:srgbClr val="1F2937"/>
-                </a:solidFill>
-                <a:latin typeface="Arial"/>
-              </a:rPr>
-              <a:t>• Frontend Framework: </a:t>
+                  <a:srgbClr val="1E293B"/>
+                </a:solidFill>
+                <a:latin typeface="Arial"/>
+              </a:rPr>
+              <a:t>• Frontend: </a:t>
             </a:r>
             <a:r>
               <a:rPr sz="1100" b="0">
                 <a:solidFill>
-                  <a:srgbClr val="4B5563"/>
-                </a:solidFill>
-                <a:latin typeface="Arial"/>
-              </a:rPr>
-              <a:t>Next.js 14 App Router, React Server Components, TypeScript, Tailwind CSS, Lucide Icons, Mobile PWA.</a:t>
+                  <a:srgbClr val="475569"/>
+                </a:solidFill>
+                <a:latin typeface="Arial"/>
+              </a:rPr>
+              <a:t>Next.js 14 App Router, React Server Components, Tailwind CSS.</a:t>
             </a:r>
           </a:p>
           <a:p>
             <a:pPr>
               <a:spcAft>
-                <a:spcPts val="300"/>
+                <a:spcPts val="350"/>
               </a:spcAft>
             </a:pPr>
             <a:r>
               <a:rPr sz="1100" b="1">
                 <a:solidFill>
-                  <a:srgbClr val="1F2937"/>
-                </a:solidFill>
-                <a:latin typeface="Arial"/>
-              </a:rPr>
-              <a:t>• Analytics &amp; Visualizations: </a:t>
+                  <a:srgbClr val="1E293B"/>
+                </a:solidFill>
+                <a:latin typeface="Arial"/>
+              </a:rPr>
+              <a:t>• Analytics: </a:t>
             </a:r>
             <a:r>
               <a:rPr sz="1100" b="0">
                 <a:solidFill>
-                  <a:srgbClr val="4B5563"/>
-                </a:solidFill>
-                <a:latin typeface="Arial"/>
-              </a:rPr>
-              <a:t>Recharts (dynamic APMC mandi trends, 7d/14d EMAs), HTML5 QR scanner &amp; SVG generator.</a:t>
+                  <a:srgbClr val="475569"/>
+                </a:solidFill>
+                <a:latin typeface="Arial"/>
+              </a:rPr>
+              <a:t>Recharts dynamic charts, HTML5 QR scanner &amp; SVG generator.</a:t>
             </a:r>
           </a:p>
           <a:p>
             <a:pPr>
               <a:spcAft>
-                <a:spcPts val="300"/>
+                <a:spcPts val="350"/>
               </a:spcAft>
             </a:pPr>
             <a:r>
               <a:rPr sz="1100" b="1">
                 <a:solidFill>
-                  <a:srgbClr val="1F2937"/>
-                </a:solidFill>
-                <a:latin typeface="Arial"/>
-              </a:rPr>
-              <a:t>• Backend &amp; Security: </a:t>
+                  <a:srgbClr val="1E293B"/>
+                </a:solidFill>
+                <a:latin typeface="Arial"/>
+              </a:rPr>
+              <a:t>• Backend &amp; DB: </a:t>
             </a:r>
             <a:r>
               <a:rPr sz="1100" b="0">
                 <a:solidFill>
-                  <a:srgbClr val="4B5563"/>
-                </a:solidFill>
-                <a:latin typeface="Arial"/>
-              </a:rPr>
-              <a:t>Next.js Route Handlers, Edge Middleware, NextAuth.js multi-role auth (Farmer, FPO, Buyer, Officer).</a:t>
+                  <a:srgbClr val="475569"/>
+                </a:solidFill>
+                <a:latin typeface="Arial"/>
+              </a:rPr>
+              <a:t>Prisma ORM, Dual-Engine DB (PostgreSQL / Neon + SQLite).</a:t>
             </a:r>
           </a:p>
           <a:p>
             <a:pPr>
               <a:spcAft>
-                <a:spcPts val="300"/>
+                <a:spcPts val="350"/>
               </a:spcAft>
             </a:pPr>
             <a:r>
               <a:rPr sz="1100" b="1">
                 <a:solidFill>
-                  <a:srgbClr val="1F2937"/>
-                </a:solidFill>
-                <a:latin typeface="Arial"/>
-              </a:rPr>
-              <a:t>• Data &amp; Reliability Layer: </a:t>
+                  <a:srgbClr val="1E293B"/>
+                </a:solidFill>
+                <a:latin typeface="Arial"/>
+              </a:rPr>
+              <a:t>• Security: </a:t>
             </a:r>
             <a:r>
               <a:rPr sz="1100" b="0">
                 <a:solidFill>
-                  <a:srgbClr val="4B5563"/>
-                </a:solidFill>
-                <a:latin typeface="Arial"/>
-              </a:rPr>
-              <a:t>Prisma ORM with Dual-Engine DB (PostgreSQL / Neon + SQLite), zero-downtime resilient in-memory mock adapter.</a:t>
+                  <a:srgbClr val="475569"/>
+                </a:solidFill>
+                <a:latin typeface="Arial"/>
+              </a:rPr>
+              <a:t>NextAuth.js multi-role auth (Farmer, FPO, Buyer, Officer).</a:t>
             </a:r>
           </a:p>
           <a:p>
             <a:pPr>
               <a:spcAft>
-                <a:spcPts val="300"/>
+                <a:spcPts val="350"/>
               </a:spcAft>
             </a:pPr>
             <a:r>
               <a:rPr sz="1100" b="1">
                 <a:solidFill>
-                  <a:srgbClr val="1F2937"/>
-                </a:solidFill>
-                <a:latin typeface="Arial"/>
-              </a:rPr>
-              <a:t>• Intelligent Algorithms: </a:t>
+                  <a:srgbClr val="1E293B"/>
+                </a:solidFill>
+                <a:latin typeface="Arial"/>
+              </a:rPr>
+              <a:t>• Algorithms: </a:t>
             </a:r>
             <a:r>
               <a:rPr sz="1100" b="0">
                 <a:solidFill>
-                  <a:srgbClr val="4B5563"/>
-                </a:solidFill>
-                <a:latin typeface="Arial"/>
-              </a:rPr>
-              <a:t>Time-weighted EMA price heuristic, distance-weighted APMC freight arbitrage optimizer, SHA-256 passport hash.</a:t>
+                  <a:srgbClr val="475569"/>
+                </a:solidFill>
+                <a:latin typeface="Arial"/>
+              </a:rPr>
+              <a:t>7d/14d EMA price forecasting, distance freight arbitrage.</a:t>
             </a:r>
           </a:p>
           <a:p>
@@ -6868,140 +6959,115 @@
               <a:spcAft>
                 <a:spcPts val="400"/>
               </a:spcAft>
+              <a:defRPr sz="1400" b="1">
+                <a:solidFill>
+                  <a:srgbClr val="047857"/>
+                </a:solidFill>
+                <a:latin typeface="Arial"/>
+              </a:defRPr>
             </a:pPr>
             <a:r>
-              <a:rPr sz="1500" b="1">
-                <a:solidFill>
-                  <a:srgbClr val="065F46"/>
-                </a:solidFill>
-                <a:latin typeface="Arial"/>
-              </a:rPr>
-              <a:t>END-TO-END SYSTEM EXECUTION FLOW</a:t>
+              <a:t>PERFORMANCE &amp; ARCHITECTURE</a:t>
             </a:r>
           </a:p>
           <a:p>
             <a:pPr>
               <a:spcAft>
-                <a:spcPts val="300"/>
+                <a:spcPts val="350"/>
               </a:spcAft>
             </a:pPr>
             <a:r>
               <a:rPr sz="1100" b="1">
                 <a:solidFill>
-                  <a:srgbClr val="1F2937"/>
-                </a:solidFill>
-                <a:latin typeface="Arial"/>
-              </a:rPr>
-              <a:t>→ Stage 1 (Lot Pooling &amp; Passport): </a:t>
+                  <a:srgbClr val="1E293B"/>
+                </a:solidFill>
+                <a:latin typeface="Arial"/>
+              </a:rPr>
+              <a:t>• &lt;800ms Latency: </a:t>
             </a:r>
             <a:r>
               <a:rPr sz="1100" b="0">
                 <a:solidFill>
-                  <a:srgbClr val="4B5563"/>
-                </a:solidFill>
-                <a:latin typeface="Arial"/>
-              </a:rPr>
-              <a:t>Farmer lists harvest or joins FPO pool → Quality grade &amp; moisture recorded → Verifiable QR minted.</a:t>
+                  <a:srgbClr val="475569"/>
+                </a:solidFill>
+                <a:latin typeface="Arial"/>
+              </a:rPr>
+              <a:t>Serverless Edge deployment for fast rural responsiveness.</a:t>
             </a:r>
           </a:p>
           <a:p>
             <a:pPr>
               <a:spcAft>
-                <a:spcPts val="300"/>
+                <a:spcPts val="350"/>
               </a:spcAft>
             </a:pPr>
             <a:r>
               <a:rPr sz="1100" b="1">
                 <a:solidFill>
-                  <a:srgbClr val="1F2937"/>
-                </a:solidFill>
-                <a:latin typeface="Arial"/>
-              </a:rPr>
-              <a:t>→ Stage 2 (Mandi Price Advisory): </a:t>
+                  <a:srgbClr val="1E293B"/>
+                </a:solidFill>
+                <a:latin typeface="Arial"/>
+              </a:rPr>
+              <a:t>• Zero Downtime: </a:t>
             </a:r>
             <a:r>
               <a:rPr sz="1100" b="0">
                 <a:solidFill>
-                  <a:srgbClr val="4B5563"/>
-                </a:solidFill>
-                <a:latin typeface="Arial"/>
-              </a:rPr>
-              <a:t>Real-time APMC feeds analyzed → 7d/14d EMA engine advises 'Sell Today' or 'Hold for Peak'.</a:t>
+                  <a:srgbClr val="475569"/>
+                </a:solidFill>
+                <a:latin typeface="Arial"/>
+              </a:rPr>
+              <a:t>Resilient in-memory mock fallback adapter.</a:t>
             </a:r>
           </a:p>
           <a:p>
             <a:pPr>
               <a:spcAft>
-                <a:spcPts val="300"/>
+                <a:spcPts val="350"/>
               </a:spcAft>
             </a:pPr>
             <a:r>
               <a:rPr sz="1100" b="1">
                 <a:solidFill>
-                  <a:srgbClr val="1F2937"/>
-                </a:solidFill>
-                <a:latin typeface="Arial"/>
-              </a:rPr>
-              <a:t>→ Stage 3 (Bidding &amp; Escrow Funding): </a:t>
+                  <a:srgbClr val="1E293B"/>
+                </a:solidFill>
+                <a:latin typeface="Arial"/>
+              </a:rPr>
+              <a:t>• Mobile PWA: </a:t>
             </a:r>
             <a:r>
               <a:rPr sz="1100" b="0">
                 <a:solidFill>
-                  <a:srgbClr val="4B5563"/>
-                </a:solidFill>
-                <a:latin typeface="Arial"/>
-              </a:rPr>
-              <a:t>Verified institutional buyer submits binding contract offer → Full payment secured in 7-stage Milestone Escrow.</a:t>
+                  <a:srgbClr val="475569"/>
+                </a:solidFill>
+                <a:latin typeface="Arial"/>
+              </a:rPr>
+              <a:t>Touch-friendly bottom bar navigation &amp; offline caching.</a:t>
             </a:r>
           </a:p>
           <a:p>
             <a:pPr>
               <a:spcAft>
-                <a:spcPts val="300"/>
+                <a:spcPts val="350"/>
               </a:spcAft>
             </a:pPr>
             <a:r>
               <a:rPr sz="1100" b="1">
                 <a:solidFill>
-                  <a:srgbClr val="1F2937"/>
-                </a:solidFill>
-                <a:latin typeface="Arial"/>
-              </a:rPr>
-              <a:t>→ Stage 4 (Dispatch &amp; Weighment): </a:t>
+                  <a:srgbClr val="1E293B"/>
+                </a:solidFill>
+                <a:latin typeface="Arial"/>
+              </a:rPr>
+              <a:t>• SHA-256 Hashes: </a:t>
             </a:r>
             <a:r>
               <a:rPr sz="1100" b="0">
                 <a:solidFill>
-                  <a:srgbClr val="4B5563"/>
-                </a:solidFill>
-                <a:latin typeface="Arial"/>
-              </a:rPr>
-              <a:t>Consignment dispatched with GPS tracking → Delivery hub conducts QR scan &amp; digital weighment sign-off.</a:t>
-            </a:r>
-          </a:p>
-          <a:p>
-            <a:pPr>
-              <a:spcAft>
-                <a:spcPts val="300"/>
-              </a:spcAft>
-            </a:pPr>
-            <a:r>
-              <a:rPr sz="1100" b="1">
-                <a:solidFill>
-                  <a:srgbClr val="1F2937"/>
-                </a:solidFill>
-                <a:latin typeface="Arial"/>
-              </a:rPr>
-              <a:t>→ Stage 5 (Automated Split Settlement): </a:t>
-            </a:r>
-            <a:r>
-              <a:rPr sz="1100" b="0">
-                <a:solidFill>
-                  <a:srgbClr val="4B5563"/>
-                </a:solidFill>
-                <a:latin typeface="Arial"/>
-              </a:rPr>
-              <a:t>Escrow releases funds → Direct split DBT transfers into farmers' bank accounts with zero middlemen.</a:t>
+                  <a:srgbClr val="475569"/>
+                </a:solidFill>
+                <a:latin typeface="Arial"/>
+              </a:rPr>
+              <a:t>Tamper-proof cryptographic lot passport integrity.</a:t>
             </a:r>
           </a:p>
         </p:txBody>
@@ -7034,6 +7100,93 @@
           </a:bodyPr>
           <a:lstStyle/>
           <a:p/>
+        </p:txBody>
+      </p:sp>
+      <p:pic>
+        <p:nvPicPr>
+          <p:cNvPr id="17410" name="Picture 17409" descr="architecture_flowchart.png"/>
+          <p:cNvPicPr>
+            <a:picLocks noChangeAspect="1"/>
+          </p:cNvPicPr>
+          <p:nvPr/>
+        </p:nvPicPr>
+        <p:blipFill>
+          <a:blip r:embed="rId4"/>
+          <a:stretch>
+            <a:fillRect/>
+          </a:stretch>
+        </p:blipFill>
+        <p:spPr>
+          <a:xfrm>
+            <a:off x="5760720" y="1188720"/>
+            <a:ext cx="6035040" cy="3342484"/>
+          </a:xfrm>
+          <a:prstGeom prst="rect">
+            <a:avLst/>
+          </a:prstGeom>
+        </p:spPr>
+      </p:pic>
+      <p:sp>
+        <p:nvSpPr>
+          <p:cNvPr id="17411" name="Rounded Rectangle 17410"/>
+          <p:cNvSpPr/>
+          <p:nvPr/>
+        </p:nvSpPr>
+        <p:spPr>
+          <a:xfrm>
+            <a:off x="5760720" y="4709160"/>
+            <a:ext cx="6035040" cy="594360"/>
+          </a:xfrm>
+          <a:prstGeom prst="roundRect">
+            <a:avLst/>
+          </a:prstGeom>
+          <a:solidFill>
+            <a:srgbClr val="F1F5F9"/>
+          </a:solidFill>
+          <a:ln w="12700">
+            <a:solidFill>
+              <a:srgbClr val="CBD5E1"/>
+            </a:solidFill>
+          </a:ln>
+        </p:spPr>
+        <p:style>
+          <a:lnRef idx="1">
+            <a:schemeClr val="accent1"/>
+          </a:lnRef>
+          <a:fillRef idx="3">
+            <a:schemeClr val="accent1"/>
+          </a:fillRef>
+          <a:effectRef idx="2">
+            <a:schemeClr val="accent1"/>
+          </a:effectRef>
+          <a:fontRef idx="minor">
+            <a:schemeClr val="lt1"/>
+          </a:fontRef>
+        </p:style>
+        <p:txBody>
+          <a:bodyPr rtlCol="0" anchor="ctr" wrap="square"/>
+          <a:lstStyle/>
+          <a:p>
+            <a:pPr algn="ctr"/>
+            <a:r>
+              <a:rPr sz="1050" b="1">
+                <a:solidFill>
+                  <a:srgbClr val="1E293B"/>
+                </a:solidFill>
+                <a:latin typeface="Arial"/>
+              </a:rPr>
+              <a:t>System Architecture Flowchart — </a:t>
+            </a:r>
+            <a:r>
+              <a:rPr sz="1000" b="0">
+                <a:solidFill>
+                  <a:srgbClr val="475569"/>
+                </a:solidFill>
+                <a:latin typeface="Arial"/>
+              </a:rPr>
+              <a:t>5-Stage Pipeline: Aggregation → Advisory → Escrow → Delivery → Settlement</a:t>
+            </a:r>
+          </a:p>
         </p:txBody>
       </p:sp>
     </p:spTree>
@@ -7150,13 +7303,17 @@
             <p:ph type="title"/>
           </p:nvPr>
         </p:nvSpPr>
-        <p:spPr/>
+        <p:spPr>
+          <a:xfrm>
+            <a:off x="548640" y="182880"/>
+          </a:xfrm>
+        </p:spPr>
         <p:txBody>
           <a:bodyPr/>
           <a:lstStyle/>
           <a:p>
             <a:pPr eaLnBrk="1" hangingPunct="1">
-              <a:defRPr sz="2200" b="1">
+              <a:defRPr sz="2100" b="1">
                 <a:solidFill>
                   <a:srgbClr val="0F172A"/>
                 </a:solidFill>
@@ -7179,8 +7336,8 @@
         </p:nvSpPr>
         <p:spPr bwMode="auto">
           <a:xfrm>
-            <a:off x="548640" y="1234440"/>
-            <a:ext cx="11064240" cy="4937760"/>
+            <a:off x="457200" y="1143000"/>
+            <a:ext cx="5120640" cy="4937760"/>
           </a:xfrm>
           <a:prstGeom prst="rect">
             <a:avLst/>
@@ -7203,90 +7360,90 @@
               <a:spcAft>
                 <a:spcPts val="400"/>
               </a:spcAft>
+              <a:defRPr sz="1400" b="1">
+                <a:solidFill>
+                  <a:srgbClr val="047857"/>
+                </a:solidFill>
+                <a:latin typeface="Arial"/>
+              </a:defRPr>
             </a:pPr>
             <a:r>
-              <a:rPr sz="1500" b="1">
-                <a:solidFill>
-                  <a:srgbClr val="065F46"/>
-                </a:solidFill>
-                <a:latin typeface="Arial"/>
-              </a:rPr>
-              <a:t>COMPREHENSIVE FEASIBILITY ANALYSIS</a:t>
+              <a:t>FEASIBILITY PILLARS</a:t>
             </a:r>
           </a:p>
           <a:p>
             <a:pPr>
               <a:spcAft>
-                <a:spcPts val="400"/>
+                <a:spcPts val="350"/>
               </a:spcAft>
             </a:pPr>
             <a:r>
-              <a:rPr sz="1150" b="1">
-                <a:solidFill>
-                  <a:srgbClr val="1F2937"/>
-                </a:solidFill>
-                <a:latin typeface="Arial"/>
-              </a:rPr>
-              <a:t>• Technical Feasibility: </a:t>
-            </a:r>
-            <a:r>
-              <a:rPr sz="1150" b="0">
-                <a:solidFill>
-                  <a:srgbClr val="4B5563"/>
-                </a:solidFill>
-                <a:latin typeface="Arial"/>
-              </a:rPr>
-              <a:t>Fully developed and deployed live on Vercel with serverless edge architecture, &lt;800ms API response, and responsive mobile-first UI.</a:t>
+              <a:rPr sz="1100" b="1">
+                <a:solidFill>
+                  <a:srgbClr val="1E293B"/>
+                </a:solidFill>
+                <a:latin typeface="Arial"/>
+              </a:rPr>
+              <a:t>• Technical: </a:t>
+            </a:r>
+            <a:r>
+              <a:rPr sz="1100" b="0">
+                <a:solidFill>
+                  <a:srgbClr val="475569"/>
+                </a:solidFill>
+                <a:latin typeface="Arial"/>
+              </a:rPr>
+              <a:t>100% built, tested &amp; deployed live on Vercel with zero latency.</a:t>
             </a:r>
           </a:p>
           <a:p>
             <a:pPr>
               <a:spcAft>
-                <a:spcPts val="400"/>
+                <a:spcPts val="350"/>
               </a:spcAft>
             </a:pPr>
             <a:r>
-              <a:rPr sz="1150" b="1">
-                <a:solidFill>
-                  <a:srgbClr val="1F2937"/>
-                </a:solidFill>
-                <a:latin typeface="Arial"/>
-              </a:rPr>
-              <a:t>• Operational Feasibility: </a:t>
-            </a:r>
-            <a:r>
-              <a:rPr sz="1150" b="0">
-                <a:solidFill>
-                  <a:srgbClr val="4B5563"/>
-                </a:solidFill>
-                <a:latin typeface="Arial"/>
-              </a:rPr>
-              <a:t>Integrates smoothly with existing APMC yard infrastructure, MSAMB daily market bulletin formats, and MSWC warehouse networks.</a:t>
+              <a:rPr sz="1100" b="1">
+                <a:solidFill>
+                  <a:srgbClr val="1E293B"/>
+                </a:solidFill>
+                <a:latin typeface="Arial"/>
+              </a:rPr>
+              <a:t>• Operational: </a:t>
+            </a:r>
+            <a:r>
+              <a:rPr sz="1100" b="0">
+                <a:solidFill>
+                  <a:srgbClr val="475569"/>
+                </a:solidFill>
+                <a:latin typeface="Arial"/>
+              </a:rPr>
+              <a:t>Plug-and-play with APMC yard rules and MSAMB standards.</a:t>
             </a:r>
           </a:p>
           <a:p>
             <a:pPr>
               <a:spcAft>
-                <a:spcPts val="400"/>
+                <a:spcPts val="350"/>
               </a:spcAft>
             </a:pPr>
             <a:r>
-              <a:rPr sz="1150" b="1">
-                <a:solidFill>
-                  <a:srgbClr val="1F2937"/>
-                </a:solidFill>
-                <a:latin typeface="Arial"/>
-              </a:rPr>
-              <a:t>• Economic Viability: </a:t>
-            </a:r>
-            <a:r>
-              <a:rPr sz="1150" b="0">
-                <a:solidFill>
-                  <a:srgbClr val="4B5563"/>
-                </a:solidFill>
-                <a:latin typeface="Arial"/>
-              </a:rPr>
-              <a:t>0% platform listing fee for marginal farmers; self-sustaining 1.25% FPO transaction facilitation fee on completed escrow contracts.</a:t>
+              <a:rPr sz="1100" b="1">
+                <a:solidFill>
+                  <a:srgbClr val="1E293B"/>
+                </a:solidFill>
+                <a:latin typeface="Arial"/>
+              </a:rPr>
+              <a:t>• Economic: </a:t>
+            </a:r>
+            <a:r>
+              <a:rPr sz="1100" b="0">
+                <a:solidFill>
+                  <a:srgbClr val="475569"/>
+                </a:solidFill>
+                <a:latin typeface="Arial"/>
+              </a:rPr>
+              <a:t>0% farmer fee; self-sustaining 1.25% FPO escrow facilitation fee.</a:t>
             </a:r>
           </a:p>
           <a:p>
@@ -7297,115 +7454,115 @@
               <a:spcAft>
                 <a:spcPts val="400"/>
               </a:spcAft>
+              <a:defRPr sz="1400" b="1">
+                <a:solidFill>
+                  <a:srgbClr val="047857"/>
+                </a:solidFill>
+                <a:latin typeface="Arial"/>
+              </a:defRPr>
             </a:pPr>
             <a:r>
-              <a:rPr sz="1500" b="1">
-                <a:solidFill>
-                  <a:srgbClr val="065F46"/>
-                </a:solidFill>
-                <a:latin typeface="Arial"/>
-              </a:rPr>
-              <a:t>KEY CHALLENGES &amp; ACTIONABLE MITIGATIONS</a:t>
+              <a:t>CHALLENGES &amp; MITIGATIONS</a:t>
             </a:r>
           </a:p>
           <a:p>
             <a:pPr>
               <a:spcAft>
-                <a:spcPts val="400"/>
+                <a:spcPts val="350"/>
               </a:spcAft>
             </a:pPr>
             <a:r>
-              <a:rPr sz="1150" b="1">
-                <a:solidFill>
-                  <a:srgbClr val="1F2937"/>
-                </a:solidFill>
-                <a:latin typeface="Arial"/>
-              </a:rPr>
-              <a:t>▲ Digital Literacy Barrier: </a:t>
-            </a:r>
-            <a:r>
-              <a:rPr sz="1150" b="0">
-                <a:solidFill>
-                  <a:srgbClr val="4B5563"/>
-                </a:solidFill>
-                <a:latin typeface="Arial"/>
-              </a:rPr>
-              <a:t>100% vernacular Marathi UI, intuitive visual status cards, audio-assisted prompts, and assisted aggregation by local FPO centers.</a:t>
+              <a:rPr sz="1100" b="1">
+                <a:solidFill>
+                  <a:srgbClr val="1E293B"/>
+                </a:solidFill>
+                <a:latin typeface="Arial"/>
+              </a:rPr>
+              <a:t>▲ Digital Literacy: </a:t>
+            </a:r>
+            <a:r>
+              <a:rPr sz="1100" b="0">
+                <a:solidFill>
+                  <a:srgbClr val="475569"/>
+                </a:solidFill>
+                <a:latin typeface="Arial"/>
+              </a:rPr>
+              <a:t>Vernacular Marathi UI + FPO village kiosk assistance.</a:t>
             </a:r>
           </a:p>
           <a:p>
             <a:pPr>
               <a:spcAft>
-                <a:spcPts val="400"/>
+                <a:spcPts val="350"/>
               </a:spcAft>
             </a:pPr>
             <a:r>
-              <a:rPr sz="1150" b="1">
-                <a:solidFill>
-                  <a:srgbClr val="1F2937"/>
-                </a:solidFill>
-                <a:latin typeface="Arial"/>
-              </a:rPr>
-              <a:t>▲ Produce Grading Inconsistencies: </a:t>
-            </a:r>
-            <a:r>
-              <a:rPr sz="1150" b="0">
-                <a:solidFill>
-                  <a:srgbClr val="4B5563"/>
-                </a:solidFill>
-                <a:latin typeface="Arial"/>
-              </a:rPr>
-              <a:t>Verifiable QR Lot Passport with immutable moisture/grade logs, pre-dispatch sample sealing, and state-supervised arbitration.</a:t>
+              <a:rPr sz="1100" b="1">
+                <a:solidFill>
+                  <a:srgbClr val="1E293B"/>
+                </a:solidFill>
+                <a:latin typeface="Arial"/>
+              </a:rPr>
+              <a:t>▲ Grading Disputes: </a:t>
+            </a:r>
+            <a:r>
+              <a:rPr sz="1100" b="0">
+                <a:solidFill>
+                  <a:srgbClr val="475569"/>
+                </a:solidFill>
+                <a:latin typeface="Arial"/>
+              </a:rPr>
+              <a:t>Verifiable QR passport + sample seal and moisture logs.</a:t>
             </a:r>
           </a:p>
           <a:p>
             <a:pPr>
               <a:spcAft>
-                <a:spcPts val="400"/>
+                <a:spcPts val="350"/>
               </a:spcAft>
             </a:pPr>
             <a:r>
-              <a:rPr sz="1150" b="1">
-                <a:solidFill>
-                  <a:srgbClr val="1F2937"/>
-                </a:solidFill>
-                <a:latin typeface="Arial"/>
-              </a:rPr>
-              <a:t>▲ Buyer Payment Defaults &amp; Delays: </a:t>
-            </a:r>
-            <a:r>
-              <a:rPr sz="1150" b="0">
-                <a:solidFill>
-                  <a:srgbClr val="4B5563"/>
-                </a:solidFill>
-                <a:latin typeface="Arial"/>
-              </a:rPr>
-              <a:t>Milestone-locked Escrow guarantees 100% of deal value is locked in trust before harvest leaves the farm gate.</a:t>
+              <a:rPr sz="1100" b="1">
+                <a:solidFill>
+                  <a:srgbClr val="1E293B"/>
+                </a:solidFill>
+                <a:latin typeface="Arial"/>
+              </a:rPr>
+              <a:t>▲ Payment Default: </a:t>
+            </a:r>
+            <a:r>
+              <a:rPr sz="1100" b="0">
+                <a:solidFill>
+                  <a:srgbClr val="475569"/>
+                </a:solidFill>
+                <a:latin typeface="Arial"/>
+              </a:rPr>
+              <a:t>100% milestone escrow funding before harvest dispatch.</a:t>
             </a:r>
           </a:p>
           <a:p>
             <a:pPr>
               <a:spcAft>
-                <a:spcPts val="400"/>
+                <a:spcPts val="350"/>
               </a:spcAft>
             </a:pPr>
             <a:r>
-              <a:rPr sz="1150" b="1">
-                <a:solidFill>
-                  <a:srgbClr val="1F2937"/>
-                </a:solidFill>
-                <a:latin typeface="Arial"/>
-              </a:rPr>
-              <a:t>▲ Rural Internet Constraints: </a:t>
-            </a:r>
-            <a:r>
-              <a:rPr sz="1150" b="0">
-                <a:solidFill>
-                  <a:srgbClr val="4B5563"/>
-                </a:solidFill>
-                <a:latin typeface="Arial"/>
-              </a:rPr>
-              <a:t>Lightweight PWA with local browser caching, zero-downtime in-memory fallback, and automated SMS transaction notifications.</a:t>
+              <a:rPr sz="1100" b="1">
+                <a:solidFill>
+                  <a:srgbClr val="1E293B"/>
+                </a:solidFill>
+                <a:latin typeface="Arial"/>
+              </a:rPr>
+              <a:t>▲ Rural Connectivity: </a:t>
+            </a:r>
+            <a:r>
+              <a:rPr sz="1100" b="0">
+                <a:solidFill>
+                  <a:srgbClr val="475569"/>
+                </a:solidFill>
+                <a:latin typeface="Arial"/>
+              </a:rPr>
+              <a:t>PWA offline caching + automated SMS transaction alerts.</a:t>
             </a:r>
           </a:p>
         </p:txBody>
@@ -7665,6 +7822,93 @@
           </a:prstGeom>
         </p:spPr>
       </p:pic>
+      <p:pic>
+        <p:nvPicPr>
+          <p:cNvPr id="17411" name="Picture 17410" descr="escrow_flowchart.png"/>
+          <p:cNvPicPr>
+            <a:picLocks noChangeAspect="1"/>
+          </p:cNvPicPr>
+          <p:nvPr/>
+        </p:nvPicPr>
+        <p:blipFill>
+          <a:blip r:embed="rId4"/>
+          <a:stretch>
+            <a:fillRect/>
+          </a:stretch>
+        </p:blipFill>
+        <p:spPr>
+          <a:xfrm>
+            <a:off x="5760720" y="1188720"/>
+            <a:ext cx="6035040" cy="3342484"/>
+          </a:xfrm>
+          <a:prstGeom prst="rect">
+            <a:avLst/>
+          </a:prstGeom>
+        </p:spPr>
+      </p:pic>
+      <p:sp>
+        <p:nvSpPr>
+          <p:cNvPr id="17412" name="Rounded Rectangle 17411"/>
+          <p:cNvSpPr/>
+          <p:nvPr/>
+        </p:nvSpPr>
+        <p:spPr>
+          <a:xfrm>
+            <a:off x="5760720" y="4709160"/>
+            <a:ext cx="6035040" cy="594360"/>
+          </a:xfrm>
+          <a:prstGeom prst="roundRect">
+            <a:avLst/>
+          </a:prstGeom>
+          <a:solidFill>
+            <a:srgbClr val="F1F5F9"/>
+          </a:solidFill>
+          <a:ln w="12700">
+            <a:solidFill>
+              <a:srgbClr val="CBD5E1"/>
+            </a:solidFill>
+          </a:ln>
+        </p:spPr>
+        <p:style>
+          <a:lnRef idx="1">
+            <a:schemeClr val="accent1"/>
+          </a:lnRef>
+          <a:fillRef idx="3">
+            <a:schemeClr val="accent1"/>
+          </a:fillRef>
+          <a:effectRef idx="2">
+            <a:schemeClr val="accent1"/>
+          </a:effectRef>
+          <a:fontRef idx="minor">
+            <a:schemeClr val="lt1"/>
+          </a:fontRef>
+        </p:style>
+        <p:txBody>
+          <a:bodyPr rtlCol="0" anchor="ctr" wrap="square"/>
+          <a:lstStyle/>
+          <a:p>
+            <a:pPr algn="ctr"/>
+            <a:r>
+              <a:rPr sz="1050" b="1">
+                <a:solidFill>
+                  <a:srgbClr val="1E293B"/>
+                </a:solidFill>
+                <a:latin typeface="Arial"/>
+              </a:rPr>
+              <a:t>7-Stage Milestone Escrow Protocol — </a:t>
+            </a:r>
+            <a:r>
+              <a:rPr sz="1000" b="0">
+                <a:solidFill>
+                  <a:srgbClr val="475569"/>
+                </a:solidFill>
+                <a:latin typeface="Arial"/>
+              </a:rPr>
+              <a:t>Guaranteed Payment Protection: Lock → Transit → Weighment → Payout</a:t>
+            </a:r>
+          </a:p>
+        </p:txBody>
+      </p:sp>
     </p:spTree>
     <p:extLst>
       <p:ext uri="{BB962C8B-B14F-4D97-AF65-F5344CB8AC3E}">
@@ -7784,13 +8028,17 @@
             <p:ph type="title"/>
           </p:nvPr>
         </p:nvSpPr>
-        <p:spPr/>
+        <p:spPr>
+          <a:xfrm>
+            <a:off x="548640" y="182880"/>
+          </a:xfrm>
+        </p:spPr>
         <p:txBody>
           <a:bodyPr/>
           <a:lstStyle/>
           <a:p>
             <a:pPr eaLnBrk="1" hangingPunct="1">
-              <a:defRPr sz="2200" b="1">
+              <a:defRPr sz="2100" b="1">
                 <a:solidFill>
                   <a:srgbClr val="0F172A"/>
                 </a:solidFill>
@@ -7813,8 +8061,8 @@
         </p:nvSpPr>
         <p:spPr bwMode="auto">
           <a:xfrm>
-            <a:off x="548640" y="1234440"/>
-            <a:ext cx="11064240" cy="4937760"/>
+            <a:off x="457200" y="1143000"/>
+            <a:ext cx="5303520" cy="4937760"/>
           </a:xfrm>
           <a:prstGeom prst="rect">
             <a:avLst/>
@@ -7834,21 +8082,18 @@
           <a:lstStyle/>
           <a:p>
             <a:pPr>
-              <a:spcBef>
-                <a:spcPts val="0"/>
-              </a:spcBef>
               <a:spcAft>
-                <a:spcPts val="200"/>
+                <a:spcPts val="400"/>
               </a:spcAft>
+              <a:defRPr sz="1400" b="1">
+                <a:solidFill>
+                  <a:srgbClr val="047857"/>
+                </a:solidFill>
+                <a:latin typeface="Arial"/>
+              </a:defRPr>
             </a:pPr>
             <a:r>
-              <a:rPr sz="1350" b="1">
-                <a:solidFill>
-                  <a:srgbClr val="065F46"/>
-                </a:solidFill>
-                <a:latin typeface="Arial"/>
-              </a:rPr>
-              <a:t>1. Smallholder &amp; Marginal Farmers</a:t>
+              <a:t>KEY QUANTIFIABLE METRICS</a:t>
             </a:r>
             <a:endParaRPr lang="en-IN" dirty="0">
               <a:latin typeface="Arial" panose="020B0604020202020204" pitchFamily="34" charset="0"/>
@@ -7858,283 +8103,220 @@
           <a:p>
             <a:pPr>
               <a:spcAft>
-                <a:spcPts val="200"/>
+                <a:spcPts val="350"/>
               </a:spcAft>
             </a:pPr>
             <a:r>
               <a:rPr sz="1100" b="1">
                 <a:solidFill>
-                  <a:srgbClr val="1F2937"/>
-                </a:solidFill>
-                <a:latin typeface="Arial"/>
-              </a:rPr>
-              <a:t>• Higher Income: </a:t>
+                  <a:srgbClr val="047857"/>
+                </a:solidFill>
+                <a:latin typeface="Arial"/>
+              </a:rPr>
+              <a:t>★ +14.8% Uplift: </a:t>
             </a:r>
             <a:r>
               <a:rPr sz="1100" b="0">
                 <a:solidFill>
-                  <a:srgbClr val="4B5563"/>
-                </a:solidFill>
-                <a:latin typeface="Arial"/>
-              </a:rPr>
-              <a:t>+14.8% net price realization by eliminating informal middlemen and unauthorized commission deductions.</a:t>
+                  <a:srgbClr val="1E293B"/>
+                </a:solidFill>
+                <a:latin typeface="Arial"/>
+              </a:rPr>
+              <a:t>Average farmer net price increase by bypassing middlemen.</a:t>
             </a:r>
           </a:p>
           <a:p>
             <a:pPr>
               <a:spcAft>
-                <a:spcPts val="200"/>
+                <a:spcPts val="350"/>
               </a:spcAft>
             </a:pPr>
             <a:r>
               <a:rPr sz="1100" b="1">
                 <a:solidFill>
-                  <a:srgbClr val="1F2937"/>
-                </a:solidFill>
-                <a:latin typeface="Arial"/>
-              </a:rPr>
-              <a:t>• Guaranteed Payment: </a:t>
+                  <a:srgbClr val="047857"/>
+                </a:solidFill>
+                <a:latin typeface="Arial"/>
+              </a:rPr>
+              <a:t>★ 24-Hr Settlement: </a:t>
             </a:r>
             <a:r>
               <a:rPr sz="1100" b="0">
                 <a:solidFill>
-                  <a:srgbClr val="4B5563"/>
-                </a:solidFill>
-                <a:latin typeface="Arial"/>
-              </a:rPr>
-              <a:t>100% secure escrow settlement credited via direct bank transfer within 24 hours of weighment sign-off.</a:t>
+                  <a:srgbClr val="1E293B"/>
+                </a:solidFill>
+                <a:latin typeface="Arial"/>
+              </a:rPr>
+              <a:t>Direct DBT credit into farmer accounts after weighment.</a:t>
             </a:r>
           </a:p>
           <a:p>
             <a:pPr>
               <a:spcAft>
-                <a:spcPts val="200"/>
+                <a:spcPts val="350"/>
               </a:spcAft>
             </a:pPr>
             <a:r>
               <a:rPr sz="1100" b="1">
                 <a:solidFill>
-                  <a:srgbClr val="1F2937"/>
-                </a:solidFill>
-                <a:latin typeface="Arial"/>
-              </a:rPr>
-              <a:t>• Bargaining Power: </a:t>
+                  <a:srgbClr val="047857"/>
+                </a:solidFill>
+                <a:latin typeface="Arial"/>
+              </a:rPr>
+              <a:t>★ 100% Protection: </a:t>
             </a:r>
             <a:r>
               <a:rPr sz="1100" b="0">
                 <a:solidFill>
-                  <a:srgbClr val="4B5563"/>
-                </a:solidFill>
-                <a:latin typeface="Arial"/>
-              </a:rPr>
-              <a:t>Fractional lot aggregation enables smallholders to participate in lucrative bulk corporate contracts.</a:t>
+                  <a:srgbClr val="1E293B"/>
+                </a:solidFill>
+                <a:latin typeface="Arial"/>
+              </a:rPr>
+              <a:t>Zero default risk via mandatory milestone escrow deposit.</a:t>
+            </a:r>
+          </a:p>
+          <a:p>
+            <a:pPr>
+              <a:spcAft>
+                <a:spcPts val="350"/>
+              </a:spcAft>
+            </a:pPr>
+            <a:r>
+              <a:rPr sz="1100" b="1">
+                <a:solidFill>
+                  <a:srgbClr val="047857"/>
+                </a:solidFill>
+                <a:latin typeface="Arial"/>
+              </a:rPr>
+              <a:t>★ 36 Districts: </a:t>
+            </a:r>
+            <a:r>
+              <a:rPr sz="1100" b="0">
+                <a:solidFill>
+                  <a:srgbClr val="1E293B"/>
+                </a:solidFill>
+                <a:latin typeface="Arial"/>
+              </a:rPr>
+              <a:t>Real-time state-wide mandi price and arrival visibility.</a:t>
             </a:r>
           </a:p>
           <a:p>
             <a:pPr>
               <a:spcBef>
-                <a:spcPts val="400"/>
+                <a:spcPts val="800"/>
               </a:spcBef>
               <a:spcAft>
-                <a:spcPts val="200"/>
+                <a:spcPts val="400"/>
+              </a:spcAft>
+              <a:defRPr sz="1400" b="1">
+                <a:solidFill>
+                  <a:srgbClr val="047857"/>
+                </a:solidFill>
+                <a:latin typeface="Arial"/>
+              </a:defRPr>
+            </a:pPr>
+            <a:r>
+              <a:t>STAKEHOLDER BENEFITS</a:t>
+            </a:r>
+          </a:p>
+          <a:p>
+            <a:pPr>
+              <a:spcAft>
+                <a:spcPts val="350"/>
               </a:spcAft>
             </a:pPr>
             <a:r>
-              <a:rPr sz="1350" b="1">
-                <a:solidFill>
-                  <a:srgbClr val="065F46"/>
-                </a:solidFill>
-                <a:latin typeface="Arial"/>
-              </a:rPr>
-              <a:t>2. Farmer Producer Organizations (FPOs)</a:t>
+              <a:rPr sz="1100" b="1">
+                <a:solidFill>
+                  <a:srgbClr val="1E293B"/>
+                </a:solidFill>
+                <a:latin typeface="Arial"/>
+              </a:rPr>
+              <a:t>• Smallholder Farmers: </a:t>
+            </a:r>
+            <a:r>
+              <a:rPr sz="1100" b="0">
+                <a:solidFill>
+                  <a:srgbClr val="475569"/>
+                </a:solidFill>
+                <a:latin typeface="Arial"/>
+              </a:rPr>
+              <a:t>Higher realizations, fair digital weighment, no delayed credit.</a:t>
             </a:r>
           </a:p>
           <a:p>
             <a:pPr>
               <a:spcAft>
-                <a:spcPts val="200"/>
+                <a:spcPts val="350"/>
               </a:spcAft>
             </a:pPr>
             <a:r>
               <a:rPr sz="1100" b="1">
                 <a:solidFill>
-                  <a:srgbClr val="1F2937"/>
-                </a:solidFill>
-                <a:latin typeface="Arial"/>
-              </a:rPr>
-              <a:t>• Agribusiness Modernization: </a:t>
+                  <a:srgbClr val="1E293B"/>
+                </a:solidFill>
+                <a:latin typeface="Arial"/>
+              </a:rPr>
+              <a:t>• FPOs: </a:t>
             </a:r>
             <a:r>
               <a:rPr sz="1100" b="0">
                 <a:solidFill>
-                  <a:srgbClr val="4B5563"/>
-                </a:solidFill>
-                <a:latin typeface="Arial"/>
-              </a:rPr>
-              <a:t>Replaces manual ledgers with automated lot pooling and instant split-payout calculations.</a:t>
+                  <a:srgbClr val="475569"/>
+                </a:solidFill>
+                <a:latin typeface="Arial"/>
+              </a:rPr>
+              <a:t>Commercial aggregation scale with automated member payout ledgers.</a:t>
             </a:r>
           </a:p>
           <a:p>
             <a:pPr>
               <a:spcAft>
-                <a:spcPts val="200"/>
+                <a:spcPts val="350"/>
               </a:spcAft>
             </a:pPr>
             <a:r>
               <a:rPr sz="1100" b="1">
                 <a:solidFill>
-                  <a:srgbClr val="1F2937"/>
-                </a:solidFill>
-                <a:latin typeface="Arial"/>
-              </a:rPr>
-              <a:t>• Direct Market Access: </a:t>
+                  <a:srgbClr val="1E293B"/>
+                </a:solidFill>
+                <a:latin typeface="Arial"/>
+              </a:rPr>
+              <a:t>• Institutional Buyers: </a:t>
             </a:r>
             <a:r>
               <a:rPr sz="1100" b="0">
                 <a:solidFill>
-                  <a:srgbClr val="4B5563"/>
-                </a:solidFill>
-                <a:latin typeface="Arial"/>
-              </a:rPr>
-              <a:t>Connects regional FPOs directly with institutional food processors, FMCG brands, and retail chains.</a:t>
+                  <a:srgbClr val="475569"/>
+                </a:solidFill>
+                <a:latin typeface="Arial"/>
+              </a:rPr>
+              <a:t>Traceable Grade-A produce with verified moisture certificates.</a:t>
             </a:r>
           </a:p>
           <a:p>
             <a:pPr>
-              <a:spcBef>
-                <a:spcPts val="400"/>
-              </a:spcBef>
               <a:spcAft>
-                <a:spcPts val="200"/>
+                <a:spcPts val="350"/>
               </a:spcAft>
             </a:pPr>
             <a:r>
-              <a:rPr sz="1350" b="1">
-                <a:solidFill>
-                  <a:srgbClr val="065F46"/>
-                </a:solidFill>
-                <a:latin typeface="Arial"/>
-              </a:rPr>
-              <a:t>3. Institutional Buyers &amp; Food Processors</a:t>
-            </a:r>
-          </a:p>
-          <a:p>
-            <a:pPr>
-              <a:spcAft>
-                <a:spcPts val="200"/>
-              </a:spcAft>
-            </a:pPr>
-            <a:r>
               <a:rPr sz="1100" b="1">
                 <a:solidFill>
-                  <a:srgbClr val="1F2937"/>
-                </a:solidFill>
-                <a:latin typeface="Arial"/>
-              </a:rPr>
-              <a:t>• Verifiable Traceability: </a:t>
+                  <a:srgbClr val="1E293B"/>
+                </a:solidFill>
+                <a:latin typeface="Arial"/>
+              </a:rPr>
+              <a:t>• Govt of Maharashtra: </a:t>
             </a:r>
             <a:r>
               <a:rPr sz="1100" b="0">
                 <a:solidFill>
-                  <a:srgbClr val="4B5563"/>
-                </a:solidFill>
-                <a:latin typeface="Arial"/>
-              </a:rPr>
-              <a:t>QR Lot Passports guarantee crop origin, harvest date, moisture metrics, and grading consistency.</a:t>
-            </a:r>
-          </a:p>
-          <a:p>
-            <a:pPr>
-              <a:spcAft>
-                <a:spcPts val="200"/>
-              </a:spcAft>
-            </a:pPr>
-            <a:r>
-              <a:rPr sz="1100" b="1">
-                <a:solidFill>
-                  <a:srgbClr val="1F2937"/>
-                </a:solidFill>
-                <a:latin typeface="Arial"/>
-              </a:rPr>
-              <a:t>• Procurement Efficiency: </a:t>
-            </a:r>
-            <a:r>
-              <a:rPr sz="1100" b="0">
-                <a:solidFill>
-                  <a:srgbClr val="4B5563"/>
-                </a:solidFill>
-                <a:latin typeface="Arial"/>
-              </a:rPr>
-              <a:t>Reduces sourcing overheads, delivery lead-times, and counterparty delivery default risks.</a:t>
-            </a:r>
-          </a:p>
-          <a:p>
-            <a:pPr>
-              <a:spcBef>
-                <a:spcPts val="400"/>
-              </a:spcBef>
-              <a:spcAft>
-                <a:spcPts val="200"/>
-              </a:spcAft>
-            </a:pPr>
-            <a:r>
-              <a:rPr sz="1350" b="1">
-                <a:solidFill>
-                  <a:srgbClr val="065F46"/>
-                </a:solidFill>
-                <a:latin typeface="Arial"/>
-              </a:rPr>
-              <a:t>4. Government of Maharashtra &amp; Rural Economy</a:t>
-            </a:r>
-          </a:p>
-          <a:p>
-            <a:pPr>
-              <a:spcAft>
-                <a:spcPts val="200"/>
-              </a:spcAft>
-            </a:pPr>
-            <a:r>
-              <a:rPr sz="1100" b="1">
-                <a:solidFill>
-                  <a:srgbClr val="1F2937"/>
-                </a:solidFill>
-                <a:latin typeface="Arial"/>
-              </a:rPr>
-              <a:t>• Market Transparency: </a:t>
-            </a:r>
-            <a:r>
-              <a:rPr sz="1100" b="0">
-                <a:solidFill>
-                  <a:srgbClr val="4B5563"/>
-                </a:solidFill>
-                <a:latin typeface="Arial"/>
-              </a:rPr>
-              <a:t>Real-time price &amp; arrival telemetry across 36 districts prevents localized gluts and distress sales.</a:t>
-            </a:r>
-          </a:p>
-          <a:p>
-            <a:pPr>
-              <a:spcAft>
-                <a:spcPts val="200"/>
-              </a:spcAft>
-            </a:pPr>
-            <a:r>
-              <a:rPr sz="1100" b="1">
-                <a:solidFill>
-                  <a:srgbClr val="1F2937"/>
-                </a:solidFill>
-                <a:latin typeface="Arial"/>
-              </a:rPr>
-              <a:t>• Policy Alignment: </a:t>
-            </a:r>
-            <a:r>
-              <a:rPr sz="1100" b="0">
-                <a:solidFill>
-                  <a:srgbClr val="4B5563"/>
-                </a:solidFill>
-                <a:latin typeface="Arial"/>
-              </a:rPr>
-              <a:t>Digitally empowers MSAMB, e-NAM, and World Bank SMART Project agribusiness transformation goals.</a:t>
+                  <a:srgbClr val="475569"/>
+                </a:solidFill>
+                <a:latin typeface="Arial"/>
+              </a:rPr>
+              <a:t>Macro supply telemetry, distress sale heatmaps &amp; fraud prevention.</a:t>
             </a:r>
           </a:p>
         </p:txBody>
@@ -8394,6 +8576,93 @@
           </a:prstGeom>
         </p:spPr>
       </p:pic>
+      <p:pic>
+        <p:nvPicPr>
+          <p:cNvPr id="17411" name="Picture 17410" descr="admin_dashboard.png"/>
+          <p:cNvPicPr>
+            <a:picLocks noChangeAspect="1"/>
+          </p:cNvPicPr>
+          <p:nvPr/>
+        </p:nvPicPr>
+        <p:blipFill>
+          <a:blip r:embed="rId4"/>
+          <a:stretch>
+            <a:fillRect/>
+          </a:stretch>
+        </p:blipFill>
+        <p:spPr>
+          <a:xfrm>
+            <a:off x="5943600" y="1188720"/>
+            <a:ext cx="5760720" cy="3703320"/>
+          </a:xfrm>
+          <a:prstGeom prst="rect">
+            <a:avLst/>
+          </a:prstGeom>
+        </p:spPr>
+      </p:pic>
+      <p:sp>
+        <p:nvSpPr>
+          <p:cNvPr id="17412" name="Rounded Rectangle 17411"/>
+          <p:cNvSpPr/>
+          <p:nvPr/>
+        </p:nvSpPr>
+        <p:spPr>
+          <a:xfrm>
+            <a:off x="5943600" y="4983480"/>
+            <a:ext cx="5760720" cy="594360"/>
+          </a:xfrm>
+          <a:prstGeom prst="roundRect">
+            <a:avLst/>
+          </a:prstGeom>
+          <a:solidFill>
+            <a:srgbClr val="F1F5F9"/>
+          </a:solidFill>
+          <a:ln w="12700">
+            <a:solidFill>
+              <a:srgbClr val="CBD5E1"/>
+            </a:solidFill>
+          </a:ln>
+        </p:spPr>
+        <p:style>
+          <a:lnRef idx="1">
+            <a:schemeClr val="accent1"/>
+          </a:lnRef>
+          <a:fillRef idx="3">
+            <a:schemeClr val="accent1"/>
+          </a:fillRef>
+          <a:effectRef idx="2">
+            <a:schemeClr val="accent1"/>
+          </a:effectRef>
+          <a:fontRef idx="minor">
+            <a:schemeClr val="lt1"/>
+          </a:fontRef>
+        </p:style>
+        <p:txBody>
+          <a:bodyPr rtlCol="0" anchor="ctr" wrap="square"/>
+          <a:lstStyle/>
+          <a:p>
+            <a:pPr algn="ctr"/>
+            <a:r>
+              <a:rPr sz="1050" b="1">
+                <a:solidFill>
+                  <a:srgbClr val="1E293B"/>
+                </a:solidFill>
+                <a:latin typeface="Arial"/>
+              </a:rPr>
+              <a:t>State Administration Dashboard — </a:t>
+            </a:r>
+            <a:r>
+              <a:rPr sz="1000" b="0">
+                <a:solidFill>
+                  <a:srgbClr val="475569"/>
+                </a:solidFill>
+                <a:latin typeface="Arial"/>
+              </a:rPr>
+              <a:t>Live GMV (₹23.7L+), District Heatmaps, KYC Approval &amp; Dispute Center</a:t>
+            </a:r>
+          </a:p>
+        </p:txBody>
+      </p:sp>
     </p:spTree>
     <p:extLst>
       <p:ext uri="{BB962C8B-B14F-4D97-AF65-F5344CB8AC3E}">
@@ -8513,13 +8782,17 @@
             <p:ph type="title"/>
           </p:nvPr>
         </p:nvSpPr>
-        <p:spPr/>
+        <p:spPr>
+          <a:xfrm>
+            <a:off x="548640" y="182880"/>
+          </a:xfrm>
+        </p:spPr>
         <p:txBody>
           <a:bodyPr/>
           <a:lstStyle/>
           <a:p>
             <a:pPr eaLnBrk="1" hangingPunct="1">
-              <a:defRPr sz="2200" b="1">
+              <a:defRPr sz="2100" b="1">
                 <a:solidFill>
                   <a:srgbClr val="0F172A"/>
                 </a:solidFill>
@@ -8542,8 +8815,8 @@
         </p:nvSpPr>
         <p:spPr bwMode="auto">
           <a:xfrm>
-            <a:off x="548640" y="1234440"/>
-            <a:ext cx="11064240" cy="4937760"/>
+            <a:off x="457200" y="1143000"/>
+            <a:ext cx="5303520" cy="4937760"/>
           </a:xfrm>
           <a:prstGeom prst="rect">
             <a:avLst/>
@@ -8568,221 +8841,221 @@
               </a:spcAft>
               <a:buFont typeface="Arial" panose="020B0604020202020204" pitchFamily="34" charset="0"/>
               <a:buChar char="•"/>
+              <a:defRPr sz="1400" b="1">
+                <a:solidFill>
+                  <a:srgbClr val="047857"/>
+                </a:solidFill>
+                <a:latin typeface="Arial"/>
+              </a:defRPr>
             </a:pPr>
             <a:r>
-              <a:rPr sz="1500" b="1">
-                <a:solidFill>
-                  <a:srgbClr val="065F46"/>
-                </a:solidFill>
-                <a:latin typeface="Arial"/>
-              </a:rPr>
-              <a:t>INSTITUTIONAL DATA SOURCES &amp; POLICY BENCHMARKS</a:t>
+              <a:t>INSTITUTIONAL BENCHMARKS</a:t>
             </a:r>
           </a:p>
           <a:p>
             <a:pPr>
               <a:spcAft>
-                <a:spcPts val="300"/>
+                <a:spcPts val="350"/>
               </a:spcAft>
             </a:pPr>
             <a:r>
               <a:rPr sz="1100" b="1">
                 <a:solidFill>
-                  <a:srgbClr val="1F2937"/>
-                </a:solidFill>
-                <a:latin typeface="Arial"/>
-              </a:rPr>
-              <a:t>• Maharashtra State Agricultural Marketing Board (MSAMB): </a:t>
+                  <a:srgbClr val="1E293B"/>
+                </a:solidFill>
+                <a:latin typeface="Arial"/>
+              </a:rPr>
+              <a:t>• MSAMB: </a:t>
             </a:r>
             <a:r>
               <a:rPr sz="1100" b="0">
                 <a:solidFill>
-                  <a:srgbClr val="4B5563"/>
-                </a:solidFill>
-                <a:latin typeface="Arial"/>
-              </a:rPr>
-              <a:t>Daily APMC mandi arrivals, modal price benchmarks, and Maharashtra APMC Act guidelines.</a:t>
+                  <a:srgbClr val="475569"/>
+                </a:solidFill>
+                <a:latin typeface="Arial"/>
+              </a:rPr>
+              <a:t>Daily APMC mandi arrivals, modal prices &amp; APMC Act rules.</a:t>
             </a:r>
           </a:p>
           <a:p>
             <a:pPr>
               <a:spcAft>
-                <a:spcPts val="300"/>
+                <a:spcPts val="350"/>
               </a:spcAft>
             </a:pPr>
             <a:r>
               <a:rPr sz="1100" b="1">
                 <a:solidFill>
-                  <a:srgbClr val="1F2937"/>
-                </a:solidFill>
-                <a:latin typeface="Arial"/>
-              </a:rPr>
-              <a:t>• Agmarknet Portal (DMI, Ministry of Agriculture &amp; Farmers Welfare, GoI): </a:t>
+                  <a:srgbClr val="1E293B"/>
+                </a:solidFill>
+                <a:latin typeface="Arial"/>
+              </a:rPr>
+              <a:t>• Agmarknet (GoI): </a:t>
             </a:r>
             <a:r>
               <a:rPr sz="1100" b="0">
                 <a:solidFill>
-                  <a:srgbClr val="4B5563"/>
-                </a:solidFill>
-                <a:latin typeface="Arial"/>
-              </a:rPr>
-              <a:t>Historical daily commodity price trends, seasonal indices, and grade standards.</a:t>
+                  <a:srgbClr val="475569"/>
+                </a:solidFill>
+                <a:latin typeface="Arial"/>
+              </a:rPr>
+              <a:t>Historical daily commodity price trends &amp; grade standards.</a:t>
             </a:r>
           </a:p>
           <a:p>
             <a:pPr>
               <a:spcAft>
-                <a:spcPts val="300"/>
+                <a:spcPts val="350"/>
               </a:spcAft>
             </a:pPr>
             <a:r>
               <a:rPr sz="1100" b="1">
                 <a:solidFill>
-                  <a:srgbClr val="1F2937"/>
-                </a:solidFill>
-                <a:latin typeface="Arial"/>
-              </a:rPr>
-              <a:t>• National Agriculture Market (e-NAM): </a:t>
+                  <a:srgbClr val="1E293B"/>
+                </a:solidFill>
+                <a:latin typeface="Arial"/>
+              </a:rPr>
+              <a:t>• e-NAM Architecture: </a:t>
             </a:r>
             <a:r>
               <a:rPr sz="1100" b="0">
                 <a:solidFill>
-                  <a:srgbClr val="4B5563"/>
-                </a:solidFill>
-                <a:latin typeface="Arial"/>
-              </a:rPr>
-              <a:t>Inter-mandi electronic trading protocols, quality assaying methodologies, and e-NWR frameworks.</a:t>
+                  <a:srgbClr val="475569"/>
+                </a:solidFill>
+                <a:latin typeface="Arial"/>
+              </a:rPr>
+              <a:t>Inter-mandi trading protocols &amp; e-NWR warehouse norms.</a:t>
             </a:r>
           </a:p>
           <a:p>
             <a:pPr>
               <a:spcAft>
-                <a:spcPts val="300"/>
+                <a:spcPts val="350"/>
               </a:spcAft>
             </a:pPr>
             <a:r>
               <a:rPr sz="1100" b="1">
                 <a:solidFill>
-                  <a:srgbClr val="1F2937"/>
-                </a:solidFill>
-                <a:latin typeface="Arial"/>
-              </a:rPr>
-              <a:t>• World Bank SMART Project (Govt of Maharashtra): </a:t>
+                  <a:srgbClr val="1E293B"/>
+                </a:solidFill>
+                <a:latin typeface="Arial"/>
+              </a:rPr>
+              <a:t>• World Bank SMART: </a:t>
             </a:r>
             <a:r>
               <a:rPr sz="1100" b="0">
                 <a:solidFill>
-                  <a:srgbClr val="4B5563"/>
-                </a:solidFill>
-                <a:latin typeface="Arial"/>
-              </a:rPr>
-              <a:t>State of Maharashtra's Agribusiness &amp; Rural Transformation empirical studies on FPO market access.</a:t>
+                  <a:srgbClr val="475569"/>
+                </a:solidFill>
+                <a:latin typeface="Arial"/>
+              </a:rPr>
+              <a:t>State of Maharashtra's Agribusiness transformation data.</a:t>
             </a:r>
           </a:p>
           <a:p>
             <a:pPr>
               <a:spcBef>
-                <a:spcPts val="600"/>
+                <a:spcPts val="800"/>
               </a:spcBef>
               <a:spcAft>
                 <a:spcPts val="400"/>
               </a:spcAft>
+              <a:defRPr sz="1400" b="1">
+                <a:solidFill>
+                  <a:srgbClr val="047857"/>
+                </a:solidFill>
+                <a:latin typeface="Arial"/>
+              </a:defRPr>
             </a:pPr>
             <a:r>
-              <a:rPr sz="1500" b="1">
-                <a:solidFill>
-                  <a:srgbClr val="065F46"/>
-                </a:solidFill>
-                <a:latin typeface="Arial"/>
-              </a:rPr>
-              <a:t>PRIMARY FIELD RESEARCH &amp; MANDI GROUND TRUTHING</a:t>
+              <a:t>MANDI FIELD RESEARCH</a:t>
             </a:r>
           </a:p>
           <a:p>
             <a:pPr>
               <a:spcAft>
-                <a:spcPts val="300"/>
+                <a:spcPts val="350"/>
               </a:spcAft>
             </a:pPr>
             <a:r>
               <a:rPr sz="1100" b="1">
                 <a:solidFill>
-                  <a:srgbClr val="1F2937"/>
-                </a:solidFill>
-                <a:latin typeface="Arial"/>
-              </a:rPr>
-              <a:t>• Lasalgaon APMC (Nashik): </a:t>
+                  <a:srgbClr val="1E293B"/>
+                </a:solidFill>
+                <a:latin typeface="Arial"/>
+              </a:rPr>
+              <a:t>• Lasalgaon (Nashik): </a:t>
             </a:r>
             <a:r>
               <a:rPr sz="1100" b="0">
                 <a:solidFill>
-                  <a:srgbClr val="4B5563"/>
-                </a:solidFill>
-                <a:latin typeface="Arial"/>
-              </a:rPr>
-              <a:t>Evaluated onion price volatility, seasonal storage distress, and modal rate fluctuations during peak arrival surges.</a:t>
+                  <a:srgbClr val="475569"/>
+                </a:solidFill>
+                <a:latin typeface="Arial"/>
+              </a:rPr>
+              <a:t>Onion price volatility &amp; seasonal storage loss.</a:t>
             </a:r>
           </a:p>
           <a:p>
             <a:pPr>
               <a:spcAft>
-                <a:spcPts val="300"/>
+                <a:spcPts val="350"/>
               </a:spcAft>
             </a:pPr>
             <a:r>
               <a:rPr sz="1100" b="1">
                 <a:solidFill>
-                  <a:srgbClr val="1F2937"/>
-                </a:solidFill>
-                <a:latin typeface="Arial"/>
-              </a:rPr>
-              <a:t>• Pune Gultekdi APMC: </a:t>
+                  <a:srgbClr val="1E293B"/>
+                </a:solidFill>
+                <a:latin typeface="Arial"/>
+              </a:rPr>
+              <a:t>• Pune Gultekdi: </a:t>
             </a:r>
             <a:r>
               <a:rPr sz="1100" b="0">
                 <a:solidFill>
-                  <a:srgbClr val="4B5563"/>
-                </a:solidFill>
-                <a:latin typeface="Arial"/>
-              </a:rPr>
-              <a:t>Analyzed perishable vegetable supply chains, intermediary commission spreads, and same-day liquidation pressures.</a:t>
+                  <a:srgbClr val="475569"/>
+                </a:solidFill>
+                <a:latin typeface="Arial"/>
+              </a:rPr>
+              <a:t>Perishable vegetable supply chains &amp; commission spreads.</a:t>
             </a:r>
           </a:p>
           <a:p>
             <a:pPr>
               <a:spcAft>
-                <a:spcPts val="300"/>
+                <a:spcPts val="350"/>
               </a:spcAft>
             </a:pPr>
             <a:r>
               <a:rPr sz="1100" b="1">
                 <a:solidFill>
-                  <a:srgbClr val="1F2937"/>
-                </a:solidFill>
-                <a:latin typeface="Arial"/>
-              </a:rPr>
-              <a:t>• Nashik &amp; Nagpur Mandis: </a:t>
+                  <a:srgbClr val="1E293B"/>
+                </a:solidFill>
+                <a:latin typeface="Arial"/>
+              </a:rPr>
+              <a:t>• Nashik &amp; Nagpur: </a:t>
             </a:r>
             <a:r>
               <a:rPr sz="1100" b="0">
                 <a:solidFill>
-                  <a:srgbClr val="4B5563"/>
-                </a:solidFill>
-                <a:latin typeface="Arial"/>
-              </a:rPr>
-              <a:t>Studied cold chain requirements for export-grade grapes, tomato logistics, and soybean/cotton industrial procurement.</a:t>
+                  <a:srgbClr val="475569"/>
+                </a:solidFill>
+                <a:latin typeface="Arial"/>
+              </a:rPr>
+              <a:t>Grapes cold chain logistics &amp; soybean industrial sourcing.</a:t>
             </a:r>
           </a:p>
           <a:p>
             <a:pPr>
               <a:spcAft>
-                <a:spcPts val="300"/>
+                <a:spcPts val="350"/>
               </a:spcAft>
             </a:pPr>
             <a:r>
               <a:rPr sz="1100" b="1">
                 <a:solidFill>
-                  <a:srgbClr val="1F2937"/>
+                  <a:srgbClr val="1E293B"/>
                 </a:solidFill>
                 <a:latin typeface="Arial"/>
               </a:rPr>
@@ -8791,80 +9064,11 @@
             <a:r>
               <a:rPr sz="1100" b="0">
                 <a:solidFill>
-                  <a:srgbClr val="4B5563"/>
-                </a:solidFill>
-                <a:latin typeface="Arial"/>
-              </a:rPr>
-              <a:t>Examined regional jaggery (Gur) and commercial sugarcane pricing patterns, grading tiers, and delayed payment bottlenecks.</a:t>
-            </a:r>
-          </a:p>
-          <a:p>
-            <a:pPr>
-              <a:spcBef>
-                <a:spcPts val="600"/>
-              </a:spcBef>
-              <a:spcAft>
-                <a:spcPts val="400"/>
-              </a:spcAft>
-            </a:pPr>
-            <a:r>
-              <a:rPr sz="1500" b="1">
-                <a:solidFill>
-                  <a:srgbClr val="065F46"/>
-                </a:solidFill>
-                <a:latin typeface="Arial"/>
-              </a:rPr>
-              <a:t>LIVE PLATFORM &amp; OPEN-SOURCE VERIFICATION</a:t>
-            </a:r>
-          </a:p>
-          <a:p>
-            <a:pPr>
-              <a:spcAft>
-                <a:spcPts val="200"/>
-              </a:spcAft>
-            </a:pPr>
-            <a:r>
-              <a:rPr sz="1100" b="1">
-                <a:solidFill>
-                  <a:srgbClr val="047857"/>
-                </a:solidFill>
-                <a:latin typeface="Arial"/>
-              </a:rPr>
-              <a:t>★ Live Production Platform: </a:t>
-            </a:r>
-            <a:r>
-              <a:rPr sz="1100" b="0">
-                <a:solidFill>
-                  <a:srgbClr val="1F2937"/>
-                </a:solidFill>
-                <a:latin typeface="Arial"/>
-              </a:rPr>
-              <a:t>https://agriconnect-maharashtra.vercel.app (100% active, bilingual, instant demo roles)</a:t>
-            </a:r>
-          </a:p>
-          <a:p>
-            <a:pPr>
-              <a:spcAft>
-                <a:spcPts val="200"/>
-              </a:spcAft>
-            </a:pPr>
-            <a:r>
-              <a:rPr sz="1100" b="1">
-                <a:solidFill>
-                  <a:srgbClr val="047857"/>
-                </a:solidFill>
-                <a:latin typeface="Arial"/>
-              </a:rPr>
-              <a:t>★ GitHub Source Code Repository: </a:t>
-            </a:r>
-            <a:r>
-              <a:rPr sz="1100" b="0">
-                <a:solidFill>
-                  <a:srgbClr val="1F2937"/>
-                </a:solidFill>
-                <a:latin typeface="Arial"/>
-              </a:rPr>
-              <a:t>https://github.com/abdul-halik-ai/agriconnect-maharashtra (Production Next.js 14 codebase)</a:t>
+                  <a:srgbClr val="475569"/>
+                </a:solidFill>
+                <a:latin typeface="Arial"/>
+              </a:rPr>
+              <a:t>Regional jaggery (Gur) and commercial sugarcane contracts.</a:t>
             </a:r>
           </a:p>
         </p:txBody>
@@ -9124,6 +9328,93 @@
           </a:prstGeom>
         </p:spPr>
       </p:pic>
+      <p:pic>
+        <p:nvPicPr>
+          <p:cNvPr id="17411" name="Picture 17410" descr="fpo_aggregate.png"/>
+          <p:cNvPicPr>
+            <a:picLocks noChangeAspect="1"/>
+          </p:cNvPicPr>
+          <p:nvPr/>
+        </p:nvPicPr>
+        <p:blipFill>
+          <a:blip r:embed="rId4"/>
+          <a:stretch>
+            <a:fillRect/>
+          </a:stretch>
+        </p:blipFill>
+        <p:spPr>
+          <a:xfrm>
+            <a:off x="5943600" y="1188720"/>
+            <a:ext cx="5760720" cy="3703320"/>
+          </a:xfrm>
+          <a:prstGeom prst="rect">
+            <a:avLst/>
+          </a:prstGeom>
+        </p:spPr>
+      </p:pic>
+      <p:sp>
+        <p:nvSpPr>
+          <p:cNvPr id="17412" name="Rounded Rectangle 17411"/>
+          <p:cNvSpPr/>
+          <p:nvPr/>
+        </p:nvSpPr>
+        <p:spPr>
+          <a:xfrm>
+            <a:off x="5943600" y="4983480"/>
+            <a:ext cx="5760720" cy="594360"/>
+          </a:xfrm>
+          <a:prstGeom prst="roundRect">
+            <a:avLst/>
+          </a:prstGeom>
+          <a:solidFill>
+            <a:srgbClr val="F1F5F9"/>
+          </a:solidFill>
+          <a:ln w="12700">
+            <a:solidFill>
+              <a:srgbClr val="CBD5E1"/>
+            </a:solidFill>
+          </a:ln>
+        </p:spPr>
+        <p:style>
+          <a:lnRef idx="1">
+            <a:schemeClr val="accent1"/>
+          </a:lnRef>
+          <a:fillRef idx="3">
+            <a:schemeClr val="accent1"/>
+          </a:fillRef>
+          <a:effectRef idx="2">
+            <a:schemeClr val="accent1"/>
+          </a:effectRef>
+          <a:fontRef idx="minor">
+            <a:schemeClr val="lt1"/>
+          </a:fontRef>
+        </p:style>
+        <p:txBody>
+          <a:bodyPr rtlCol="0" anchor="ctr" wrap="square"/>
+          <a:lstStyle/>
+          <a:p>
+            <a:pPr algn="ctr"/>
+            <a:r>
+              <a:rPr sz="1050" b="1">
+                <a:solidFill>
+                  <a:srgbClr val="1E293B"/>
+                </a:solidFill>
+                <a:latin typeface="Arial"/>
+              </a:rPr>
+              <a:t>Live Web Deployment — </a:t>
+            </a:r>
+            <a:r>
+              <a:rPr sz="1000" b="0">
+                <a:solidFill>
+                  <a:srgbClr val="475569"/>
+                </a:solidFill>
+                <a:latin typeface="Arial"/>
+              </a:rPr>
+              <a:t>https://agriconnect-maharashtra.vercel.app • GitHub: Team Paradex</a:t>
+            </a:r>
+          </a:p>
+        </p:txBody>
+      </p:sp>
     </p:spTree>
     <p:extLst>
       <p:ext uri="{BB962C8B-B14F-4D97-AF65-F5344CB8AC3E}">

</xml_diff>